<commit_message>
Replace the Army logo with the approved primary artwork
The file in use had the descriptor above the wordmark, carried macrons,
and used a brick red of A53332 rather than Army Red D31145, which the
guidelines list as incorrect use. Extract the primary logo from the
guidelines at 600dpi with an alpha channel, rather than recreating it,
and correct the placement aspect from 4.14 to 4.38 across the paper, the
model page and the identity board. Cover registers rebalanced for the
shorter logo. Previous file kept as nz-army-logo-superseded.png.

Co-Authored-By: Claude Fable 5 <noreply@anthropic.com>
Claude-Session: https://claude.ai/code/session_01YLo1WfwUDkbwfJEF3ZNVbB
</commit_message>
<xml_diff>
--- a/output/combat-mindset-identity.pptx
+++ b/output/combat-mindset-identity.pptx
@@ -1070,7 +1070,7 @@
         <p:spPr>
           <a:xfrm>
             <a:off x="457200" y="347472"/>
-            <a:ext cx="1481328" cy="358445"/>
+            <a:ext cx="1481328" cy="338328"/>
           </a:xfrm>
           <a:prstGeom prst="rect">
             <a:avLst/>
@@ -2768,7 +2768,7 @@
         <p:spPr>
           <a:xfrm>
             <a:off x="457200" y="347472"/>
-            <a:ext cx="1481328" cy="358445"/>
+            <a:ext cx="1481328" cy="338328"/>
           </a:xfrm>
           <a:prstGeom prst="rect">
             <a:avLst/>
@@ -3668,7 +3668,7 @@
         <p:spPr>
           <a:xfrm>
             <a:off x="731520" y="4261104"/>
-            <a:ext cx="1481328" cy="358445"/>
+            <a:ext cx="1481328" cy="338328"/>
           </a:xfrm>
           <a:prstGeom prst="rect">
             <a:avLst/>
@@ -3829,7 +3829,7 @@
         <p:spPr>
           <a:xfrm>
             <a:off x="4754880" y="4169664"/>
-            <a:ext cx="1225296" cy="296266"/>
+            <a:ext cx="1225296" cy="279806"/>
           </a:xfrm>
           <a:prstGeom prst="rect">
             <a:avLst/>
@@ -5573,7 +5573,7 @@
         <p:spPr>
           <a:xfrm>
             <a:off x="457200" y="347472"/>
-            <a:ext cx="1481328" cy="358445"/>
+            <a:ext cx="1481328" cy="338328"/>
           </a:xfrm>
           <a:prstGeom prst="rect">
             <a:avLst/>
@@ -5896,7 +5896,7 @@
         <p:spPr>
           <a:xfrm>
             <a:off x="640080" y="2084832"/>
-            <a:ext cx="859536" cy="207569"/>
+            <a:ext cx="859536" cy="196596"/>
           </a:xfrm>
           <a:prstGeom prst="rect">
             <a:avLst/>
@@ -6172,7 +6172,7 @@
         <p:spPr>
           <a:xfrm>
             <a:off x="3108960" y="2066544"/>
-            <a:ext cx="969264" cy="234086"/>
+            <a:ext cx="969264" cy="221285"/>
           </a:xfrm>
           <a:prstGeom prst="rect">
             <a:avLst/>
@@ -6855,7 +6855,7 @@
         <p:spPr>
           <a:xfrm>
             <a:off x="4223385" y="5916168"/>
-            <a:ext cx="804672" cy="194767"/>
+            <a:ext cx="804672" cy="183794"/>
           </a:xfrm>
           <a:prstGeom prst="rect">
             <a:avLst/>

</xml_diff>